<commit_message>
Simulator graphic: three blue panels, title-case captions, readings panel removed
Co-Authored-By: Claude Fable 5 <noreply@anthropic.com>
</commit_message>
<xml_diff>
--- a/figures/paper/fig_simulator.pptx
+++ b/figures/paper/fig_simulator.pptx
@@ -7,7 +7,7 @@
   <p:sldIdLst>
     <p:sldId id="256" r:id="rId7"/>
   </p:sldIdLst>
-  <p:sldSz cx="12539472" cy="3349752" type="screen4x3"/>
+  <p:sldSz cx="9613392" cy="3307080" type="screen4x3"/>
   <p:notesSz cx="6858000" cy="9144000"/>
   <p:defaultTextStyle>
     <a:defPPr>
@@ -3105,7 +3105,7 @@
         <p:spPr>
           <a:xfrm>
             <a:off x="0" y="0"/>
-            <a:ext cx="12539472" cy="3349752"/>
+            <a:ext cx="9613392" cy="3307080"/>
           </a:xfrm>
           <a:prstGeom prst="rect">
             <a:avLst/>

</xml_diff>